<commit_message>
Refresh hackathon submission and presentation
Expand the Devpost draft with project links, methodology, results, and team details; update the presentation files and remove the obsolete HTML preview.
</commit_message>
<xml_diff>
--- a/presentation/MatrixNotFound_Hackathon_Presentation.pptx
+++ b/presentation/MatrixNotFound_Hackathon_Presentation.pptx
@@ -5,18 +5,18 @@
     <p:sldMasterId id="2147483660" r:id="rId4"/>
   </p:sldMasterIdLst>
   <p:notesMasterIdLst>
-    <p:notesMasterId r:id="rId12"/>
+    <p:notesMasterId r:id="rId14"/>
   </p:notesMasterIdLst>
   <p:sldIdLst>
     <p:sldId id="256" r:id="rId5"/>
     <p:sldId id="258" r:id="rId6"/>
     <p:sldId id="265" r:id="rId7"/>
     <p:sldId id="262" r:id="rId8"/>
-    <p:sldId id="268" r:id="rId18"/>
-    <p:sldId id="263" r:id="rId9"/>
-    <p:sldId id="267" r:id="rId10"/>
-    <p:sldId id="269" r:id="rId19"/>
-    <p:sldId id="264" r:id="rId11"/>
+    <p:sldId id="268" r:id="rId9"/>
+    <p:sldId id="263" r:id="rId10"/>
+    <p:sldId id="267" r:id="rId11"/>
+    <p:sldId id="269" r:id="rId12"/>
+    <p:sldId id="264" r:id="rId13"/>
   </p:sldIdLst>
   <p:sldSz cx="12192000" cy="6858000"/>
   <p:notesSz cx="6858000" cy="9144000"/>
@@ -500,6 +500,76 @@
             <a:spLocks noGrp="1" noRot="1" noChangeAspect="1"/>
           </p:cNvSpPr>
           <p:nvPr>
+            <p:ph type="sldImg" idx="2"/>
+          </p:nvPr>
+        </p:nvSpPr>
+        <p:spPr/>
+      </p:sp>
+      <p:sp>
+        <p:nvSpPr>
+          <p:cNvPr id="3" name="Notes Placeholder 2"/>
+          <p:cNvSpPr>
+            <a:spLocks noGrp="1"/>
+          </p:cNvSpPr>
+          <p:nvPr>
+            <p:ph type="body" sz="quarter" idx="3"/>
+          </p:nvPr>
+        </p:nvSpPr>
+        <p:spPr/>
+        <p:txBody>
+          <a:bodyPr/>
+          <a:lstStyle/>
+          <a:p>
+            <a:r>
+              <a:t>0:00-0:15 (15 s). Hi, we're Group 1, Matrix Not Found: Yeong Sir Chung, Matthew Roberto and Rohit Panda. Our project is Retrofit Radar: predicting building energy use in MATLAB to find which buildings to retrofit first.</a:t>
+            </a:r>
+          </a:p>
+        </p:txBody>
+      </p:sp>
+      <p:sp>
+        <p:nvSpPr>
+          <p:cNvPr id="4" name="Slide Number Placeholder 3"/>
+          <p:cNvSpPr>
+            <a:spLocks noGrp="1"/>
+          </p:cNvSpPr>
+          <p:nvPr>
+            <p:ph type="sldNum" sz="quarter" idx="5"/>
+          </p:nvPr>
+        </p:nvSpPr>
+        <p:spPr/>
+      </p:sp>
+    </p:spTree>
+  </p:cSld>
+  <p:clrMapOvr>
+    <a:masterClrMapping/>
+  </p:clrMapOvr>
+</p:notes>
+</file>
+
+<file path=ppt/notesSlides/notesSlide2.xml><?xml version="1.0" encoding="utf-8"?>
+<p:notes xmlns:a="http://schemas.openxmlformats.org/drawingml/2006/main" xmlns:r="http://schemas.openxmlformats.org/officeDocument/2006/relationships" xmlns:p="http://schemas.openxmlformats.org/presentationml/2006/main">
+  <p:cSld>
+    <p:spTree>
+      <p:nvGrpSpPr>
+        <p:cNvPr id="1" name=""/>
+        <p:cNvGrpSpPr/>
+        <p:nvPr/>
+      </p:nvGrpSpPr>
+      <p:grpSpPr>
+        <a:xfrm>
+          <a:off x="0" y="0"/>
+          <a:ext cx="0" cy="0"/>
+          <a:chOff x="0" y="0"/>
+          <a:chExt cx="0" cy="0"/>
+        </a:xfrm>
+      </p:grpSpPr>
+      <p:sp>
+        <p:nvSpPr>
+          <p:cNvPr id="2" name="Slide Image Placeholder 1"/>
+          <p:cNvSpPr>
+            <a:spLocks noGrp="1" noRot="1" noChangeAspect="1"/>
+          </p:cNvSpPr>
+          <p:nvPr>
             <p:ph type="sldImg"/>
           </p:nvPr>
         </p:nvSpPr>
@@ -562,7 +632,7 @@
 </p:notes>
 </file>
 
-<file path=ppt/notesSlides/notesSlide2.xml><?xml version="1.0" encoding="utf-8"?>
+<file path=ppt/notesSlides/notesSlide3.xml><?xml version="1.0" encoding="utf-8"?>
 <p:notes xmlns:a="http://schemas.openxmlformats.org/drawingml/2006/main" xmlns:r="http://schemas.openxmlformats.org/officeDocument/2006/relationships" xmlns:p="http://schemas.openxmlformats.org/presentationml/2006/main">
   <p:cSld>
     <p:spTree>
@@ -672,7 +742,7 @@
 </p:notes>
 </file>
 
-<file path=ppt/notesSlides/notesSlide3.xml><?xml version="1.0" encoding="utf-8"?>
+<file path=ppt/notesSlides/notesSlide4.xml><?xml version="1.0" encoding="utf-8"?>
 <p:notes xmlns:a="http://schemas.openxmlformats.org/drawingml/2006/main" xmlns:r="http://schemas.openxmlformats.org/officeDocument/2006/relationships" xmlns:p="http://schemas.openxmlformats.org/presentationml/2006/main">
   <p:cSld>
     <p:spTree>
@@ -782,7 +852,77 @@
 </p:notes>
 </file>
 
-<file path=ppt/notesSlides/notesSlide4.xml><?xml version="1.0" encoding="utf-8"?>
+<file path=ppt/notesSlides/notesSlide5.xml><?xml version="1.0" encoding="utf-8"?>
+<p:notes xmlns:a="http://schemas.openxmlformats.org/drawingml/2006/main" xmlns:r="http://schemas.openxmlformats.org/officeDocument/2006/relationships" xmlns:p="http://schemas.openxmlformats.org/presentationml/2006/main">
+  <p:cSld>
+    <p:spTree>
+      <p:nvGrpSpPr>
+        <p:cNvPr id="1" name=""/>
+        <p:cNvGrpSpPr/>
+        <p:nvPr/>
+      </p:nvGrpSpPr>
+      <p:grpSpPr>
+        <a:xfrm>
+          <a:off x="0" y="0"/>
+          <a:ext cx="0" cy="0"/>
+          <a:chOff x="0" y="0"/>
+          <a:chExt cx="0" cy="0"/>
+        </a:xfrm>
+      </p:grpSpPr>
+      <p:sp>
+        <p:nvSpPr>
+          <p:cNvPr id="2" name="Slide Image Placeholder 1"/>
+          <p:cNvSpPr>
+            <a:spLocks noGrp="1" noRot="1" noChangeAspect="1"/>
+          </p:cNvSpPr>
+          <p:nvPr>
+            <p:ph type="sldImg" idx="2"/>
+          </p:nvPr>
+        </p:nvSpPr>
+        <p:spPr/>
+      </p:sp>
+      <p:sp>
+        <p:nvSpPr>
+          <p:cNvPr id="3" name="Notes Placeholder 2"/>
+          <p:cNvSpPr>
+            <a:spLocks noGrp="1"/>
+          </p:cNvSpPr>
+          <p:nvPr>
+            <p:ph type="body" sz="quarter" idx="3"/>
+          </p:nvPr>
+        </p:nvSpPr>
+        <p:spPr/>
+        <p:txBody>
+          <a:bodyPr/>
+          <a:lstStyle/>
+          <a:p>
+            <a:r>
+              <a:t>2:00-2:35 (35 s). Results under leave-one-year-out. Boosting cuts the error by a third versus a single tree. Shrinkage, v2, did not help, and we kept that result to show the iteration honestly. Feature selection, v3, dropping the monthly temperatures, gave the best score: RMSE 40.1, MAE 21, R squared 0.53, best in five of six held-out years.</a:t>
+            </a:r>
+          </a:p>
+        </p:txBody>
+      </p:sp>
+      <p:sp>
+        <p:nvSpPr>
+          <p:cNvPr id="4" name="Slide Number Placeholder 3"/>
+          <p:cNvSpPr>
+            <a:spLocks noGrp="1"/>
+          </p:cNvSpPr>
+          <p:nvPr>
+            <p:ph type="sldNum" sz="quarter" idx="5"/>
+          </p:nvPr>
+        </p:nvSpPr>
+        <p:spPr/>
+      </p:sp>
+    </p:spTree>
+  </p:cSld>
+  <p:clrMapOvr>
+    <a:masterClrMapping/>
+  </p:clrMapOvr>
+</p:notes>
+</file>
+
+<file path=ppt/notesSlides/notesSlide6.xml><?xml version="1.0" encoding="utf-8"?>
 <p:notes xmlns:a="http://schemas.openxmlformats.org/drawingml/2006/main" xmlns:r="http://schemas.openxmlformats.org/officeDocument/2006/relationships" xmlns:p="http://schemas.openxmlformats.org/presentationml/2006/main">
   <p:cSld>
     <p:spTree>
@@ -873,7 +1013,7 @@
           <a:p>
             <a:fld id="{D0281BBE-E16D-483E-8B55-501014EE2200}" type="slidenum">
               <a:rPr lang="en-CA" smtClean="0"/>
-              <a:t>5</a:t>
+              <a:t>6</a:t>
             </a:fld>
             <a:endParaRPr lang="en-CA"/>
           </a:p>
@@ -892,7 +1032,7 @@
 </p:notes>
 </file>
 
-<file path=ppt/notesSlides/notesSlide5.xml><?xml version="1.0" encoding="utf-8"?>
+<file path=ppt/notesSlides/notesSlide7.xml><?xml version="1.0" encoding="utf-8"?>
 <p:notes xmlns:a="http://schemas.openxmlformats.org/drawingml/2006/main" xmlns:r="http://schemas.openxmlformats.org/officeDocument/2006/relationships" xmlns:p="http://schemas.openxmlformats.org/presentationml/2006/main">
   <p:cSld>
     <p:spTree>
@@ -983,7 +1123,7 @@
           <a:p>
             <a:fld id="{D0281BBE-E16D-483E-8B55-501014EE2200}" type="slidenum">
               <a:rPr lang="en-CA" smtClean="0"/>
-              <a:t>6</a:t>
+              <a:t>7</a:t>
             </a:fld>
             <a:endParaRPr lang="en-CA"/>
           </a:p>
@@ -1002,7 +1142,77 @@
 </p:notes>
 </file>
 
-<file path=ppt/notesSlides/notesSlide6.xml><?xml version="1.0" encoding="utf-8"?>
+<file path=ppt/notesSlides/notesSlide8.xml><?xml version="1.0" encoding="utf-8"?>
+<p:notes xmlns:a="http://schemas.openxmlformats.org/drawingml/2006/main" xmlns:r="http://schemas.openxmlformats.org/officeDocument/2006/relationships" xmlns:p="http://schemas.openxmlformats.org/presentationml/2006/main">
+  <p:cSld>
+    <p:spTree>
+      <p:nvGrpSpPr>
+        <p:cNvPr id="1" name=""/>
+        <p:cNvGrpSpPr/>
+        <p:nvPr/>
+      </p:nvGrpSpPr>
+      <p:grpSpPr>
+        <a:xfrm>
+          <a:off x="0" y="0"/>
+          <a:ext cx="0" cy="0"/>
+          <a:chOff x="0" y="0"/>
+          <a:chExt cx="0" cy="0"/>
+        </a:xfrm>
+      </p:grpSpPr>
+      <p:sp>
+        <p:nvSpPr>
+          <p:cNvPr id="2" name="Slide Image Placeholder 1"/>
+          <p:cNvSpPr>
+            <a:spLocks noGrp="1" noRot="1" noChangeAspect="1"/>
+          </p:cNvSpPr>
+          <p:nvPr>
+            <p:ph type="sldImg" idx="2"/>
+          </p:nvPr>
+        </p:nvSpPr>
+        <p:spPr/>
+      </p:sp>
+      <p:sp>
+        <p:nvSpPr>
+          <p:cNvPr id="3" name="Notes Placeholder 2"/>
+          <p:cNvSpPr>
+            <a:spLocks noGrp="1"/>
+          </p:cNvSpPr>
+          <p:nvPr>
+            <p:ph type="body" sz="quarter" idx="3"/>
+          </p:nvPr>
+        </p:nvSpPr>
+        <p:spPr/>
+        <p:txBody>
+          <a:bodyPr/>
+          <a:lstStyle/>
+          <a:p>
+            <a:r>
+              <a:t>3:25-4:40 (75 s). SWITCH TO THE BROWSER: open index.html. (1) Dashboard: model iteration chart, then the Retrofit Radar shortlist. 1,316 buildings use at least 50% more than expected. (2) Simulator: click The Hive, press Run model: about 109 kBtu per square foot, roughly 513 kW average. Drag floor area or Energy Star to show the curve update live. The 300-tree model was exported from MATLAB and matches it exactly. Then come back to the slides.</a:t>
+            </a:r>
+          </a:p>
+        </p:txBody>
+      </p:sp>
+      <p:sp>
+        <p:nvSpPr>
+          <p:cNvPr id="4" name="Slide Number Placeholder 3"/>
+          <p:cNvSpPr>
+            <a:spLocks noGrp="1"/>
+          </p:cNvSpPr>
+          <p:nvPr>
+            <p:ph type="sldNum" sz="quarter" idx="5"/>
+          </p:nvPr>
+        </p:nvSpPr>
+        <p:spPr/>
+      </p:sp>
+    </p:spTree>
+  </p:cSld>
+  <p:clrMapOvr>
+    <a:masterClrMapping/>
+  </p:clrMapOvr>
+</p:notes>
+</file>
+
+<file path=ppt/notesSlides/notesSlide9.xml><?xml version="1.0" encoding="utf-8"?>
 <p:notes xmlns:a="http://schemas.openxmlformats.org/drawingml/2006/main" xmlns:r="http://schemas.openxmlformats.org/officeDocument/2006/relationships" xmlns:p="http://schemas.openxmlformats.org/presentationml/2006/main">
   <p:cSld>
     <p:spTree>
@@ -1093,7 +1303,7 @@
           <a:p>
             <a:fld id="{D0281BBE-E16D-483E-8B55-501014EE2200}" type="slidenum">
               <a:rPr lang="en-CA" smtClean="0"/>
-              <a:t>7</a:t>
+              <a:t>9</a:t>
             </a:fld>
             <a:endParaRPr lang="en-CA"/>
           </a:p>
@@ -1105,216 +1315,6 @@
         <p14:creationId xmlns:p14="http://schemas.microsoft.com/office/powerpoint/2010/main" val="2389624415"/>
       </p:ext>
     </p:extLst>
-  </p:cSld>
-  <p:clrMapOvr>
-    <a:masterClrMapping/>
-  </p:clrMapOvr>
-</p:notes>
-</file>
-
-<file path=ppt/notesSlides/notesSlide7.xml><?xml version="1.0" encoding="utf-8"?>
-<p:notes xmlns:a="http://schemas.openxmlformats.org/drawingml/2006/main" xmlns:p="http://schemas.openxmlformats.org/presentationml/2006/main" xmlns:r="http://schemas.openxmlformats.org/officeDocument/2006/relationships">
-  <p:cSld>
-    <p:spTree>
-      <p:nvGrpSpPr>
-        <p:cNvPr id="1" name=""/>
-        <p:cNvGrpSpPr/>
-        <p:nvPr/>
-      </p:nvGrpSpPr>
-      <p:grpSpPr>
-        <a:xfrm>
-          <a:off x="0" y="0"/>
-          <a:ext cx="0" cy="0"/>
-          <a:chOff x="0" y="0"/>
-          <a:chExt cx="0" cy="0"/>
-        </a:xfrm>
-      </p:grpSpPr>
-      <p:sp>
-        <p:nvSpPr>
-          <p:cNvPr id="2" name="Slide Image Placeholder 1"/>
-          <p:cNvSpPr>
-            <a:spLocks noGrp="1"/>
-          </p:cNvSpPr>
-          <p:nvPr>
-            <p:ph type="sldImg" idx="2"/>
-          </p:nvPr>
-        </p:nvSpPr>
-        <p:spPr/>
-      </p:sp>
-      <p:sp>
-        <p:nvSpPr>
-          <p:cNvPr id="3" name="Notes Placeholder 2"/>
-          <p:cNvSpPr>
-            <a:spLocks noGrp="1"/>
-          </p:cNvSpPr>
-          <p:nvPr>
-            <p:ph type="body" idx="3" sz="quarter"/>
-          </p:nvPr>
-        </p:nvSpPr>
-        <p:spPr/>
-        <p:txBody>
-          <a:bodyPr/>
-          <a:lstStyle/>
-          <a:p>
-            <a:r>
-              <a:t>0:00-0:15 (15 s). Hi, we're Group 1, Matrix Not Found: Yeong Sir Chung, Matthew Roberto and Rohit Panda. Our project is Retrofit Radar: predicting building energy use in MATLAB to find which buildings to retrofit first.</a:t>
-            </a:r>
-          </a:p>
-        </p:txBody>
-      </p:sp>
-      <p:sp>
-        <p:nvSpPr>
-          <p:cNvPr id="4" name="Slide Number Placeholder 3"/>
-          <p:cNvSpPr>
-            <a:spLocks noGrp="1"/>
-          </p:cNvSpPr>
-          <p:nvPr>
-            <p:ph type="sldNum" idx="5" sz="quarter"/>
-          </p:nvPr>
-        </p:nvSpPr>
-        <p:spPr/>
-      </p:sp>
-    </p:spTree>
-  </p:cSld>
-  <p:clrMapOvr>
-    <a:masterClrMapping/>
-  </p:clrMapOvr>
-</p:notes>
-</file>
-
-<file path=ppt/notesSlides/notesSlide8.xml><?xml version="1.0" encoding="utf-8"?>
-<p:notes xmlns:a="http://schemas.openxmlformats.org/drawingml/2006/main" xmlns:p="http://schemas.openxmlformats.org/presentationml/2006/main" xmlns:r="http://schemas.openxmlformats.org/officeDocument/2006/relationships">
-  <p:cSld>
-    <p:spTree>
-      <p:nvGrpSpPr>
-        <p:cNvPr id="1" name=""/>
-        <p:cNvGrpSpPr/>
-        <p:nvPr/>
-      </p:nvGrpSpPr>
-      <p:grpSpPr>
-        <a:xfrm>
-          <a:off x="0" y="0"/>
-          <a:ext cx="0" cy="0"/>
-          <a:chOff x="0" y="0"/>
-          <a:chExt cx="0" cy="0"/>
-        </a:xfrm>
-      </p:grpSpPr>
-      <p:sp>
-        <p:nvSpPr>
-          <p:cNvPr id="2" name="Slide Image Placeholder 1"/>
-          <p:cNvSpPr>
-            <a:spLocks noGrp="1"/>
-          </p:cNvSpPr>
-          <p:nvPr>
-            <p:ph type="sldImg" idx="2"/>
-          </p:nvPr>
-        </p:nvSpPr>
-        <p:spPr/>
-      </p:sp>
-      <p:sp>
-        <p:nvSpPr>
-          <p:cNvPr id="3" name="Notes Placeholder 2"/>
-          <p:cNvSpPr>
-            <a:spLocks noGrp="1"/>
-          </p:cNvSpPr>
-          <p:nvPr>
-            <p:ph type="body" idx="3" sz="quarter"/>
-          </p:nvPr>
-        </p:nvSpPr>
-        <p:spPr/>
-        <p:txBody>
-          <a:bodyPr/>
-          <a:lstStyle/>
-          <a:p>
-            <a:r>
-              <a:t>2:00-2:35 (35 s). Results under leave-one-year-out. Boosting cuts the error by a third versus a single tree. Shrinkage, v2, did not help, and we kept that result to show the iteration honestly. Feature selection, v3, dropping the monthly temperatures, gave the best score: RMSE 40.1, MAE 21, R squared 0.53, best in five of six held-out years.</a:t>
-            </a:r>
-          </a:p>
-        </p:txBody>
-      </p:sp>
-      <p:sp>
-        <p:nvSpPr>
-          <p:cNvPr id="4" name="Slide Number Placeholder 3"/>
-          <p:cNvSpPr>
-            <a:spLocks noGrp="1"/>
-          </p:cNvSpPr>
-          <p:nvPr>
-            <p:ph type="sldNum" idx="5" sz="quarter"/>
-          </p:nvPr>
-        </p:nvSpPr>
-        <p:spPr/>
-      </p:sp>
-    </p:spTree>
-  </p:cSld>
-  <p:clrMapOvr>
-    <a:masterClrMapping/>
-  </p:clrMapOvr>
-</p:notes>
-</file>
-
-<file path=ppt/notesSlides/notesSlide9.xml><?xml version="1.0" encoding="utf-8"?>
-<p:notes xmlns:a="http://schemas.openxmlformats.org/drawingml/2006/main" xmlns:p="http://schemas.openxmlformats.org/presentationml/2006/main" xmlns:r="http://schemas.openxmlformats.org/officeDocument/2006/relationships">
-  <p:cSld>
-    <p:spTree>
-      <p:nvGrpSpPr>
-        <p:cNvPr id="1" name=""/>
-        <p:cNvGrpSpPr/>
-        <p:nvPr/>
-      </p:nvGrpSpPr>
-      <p:grpSpPr>
-        <a:xfrm>
-          <a:off x="0" y="0"/>
-          <a:ext cx="0" cy="0"/>
-          <a:chOff x="0" y="0"/>
-          <a:chExt cx="0" cy="0"/>
-        </a:xfrm>
-      </p:grpSpPr>
-      <p:sp>
-        <p:nvSpPr>
-          <p:cNvPr id="2" name="Slide Image Placeholder 1"/>
-          <p:cNvSpPr>
-            <a:spLocks noGrp="1"/>
-          </p:cNvSpPr>
-          <p:nvPr>
-            <p:ph type="sldImg" idx="2"/>
-          </p:nvPr>
-        </p:nvSpPr>
-        <p:spPr/>
-      </p:sp>
-      <p:sp>
-        <p:nvSpPr>
-          <p:cNvPr id="3" name="Notes Placeholder 2"/>
-          <p:cNvSpPr>
-            <a:spLocks noGrp="1"/>
-          </p:cNvSpPr>
-          <p:nvPr>
-            <p:ph type="body" idx="3" sz="quarter"/>
-          </p:nvPr>
-        </p:nvSpPr>
-        <p:spPr/>
-        <p:txBody>
-          <a:bodyPr/>
-          <a:lstStyle/>
-          <a:p>
-            <a:r>
-              <a:t>3:25-4:40 (75 s). SWITCH TO THE BROWSER: open index.html. (1) Dashboard: model iteration chart, then the Retrofit Radar shortlist. 1,316 buildings use at least 50% more than expected. (2) Simulator: click The Hive, press Run model: about 109 kBtu per square foot, roughly 513 kW average. Drag floor area or Energy Star to show the curve update live. The 300-tree model was exported from MATLAB and matches it exactly. Then come back to the slides.</a:t>
-            </a:r>
-          </a:p>
-        </p:txBody>
-      </p:sp>
-      <p:sp>
-        <p:nvSpPr>
-          <p:cNvPr id="4" name="Slide Number Placeholder 3"/>
-          <p:cNvSpPr>
-            <a:spLocks noGrp="1"/>
-          </p:cNvSpPr>
-          <p:nvPr>
-            <p:ph type="sldNum" idx="5" sz="quarter"/>
-          </p:nvPr>
-        </p:nvSpPr>
-        <p:spPr/>
-      </p:sp>
-    </p:spTree>
   </p:cSld>
   <p:clrMapOvr>
     <a:masterClrMapping/>
@@ -10187,17 +10187,17 @@
           <a:lstStyle/>
           <a:p>
             <a:r>
-              <a:rPr lang="en-CA" sz="4000"/>
+              <a:rPr lang="en-CA" sz="4000" dirty="0"/>
               <a:t>Learn to Hack Hackathon </a:t>
             </a:r>
             <a:br>
-              <a:rPr lang="en-CA" sz="4000"/>
+              <a:rPr lang="en-CA" sz="4000" dirty="0"/>
             </a:br>
             <a:r>
-              <a:rPr lang="en-CA" b="1"/>
+              <a:rPr lang="en-CA" b="1" dirty="0"/>
               <a:t>Group 1 – Matrix Not Found</a:t>
             </a:r>
-            <a:endParaRPr lang="en-CA"/>
+            <a:endParaRPr lang="en-CA" dirty="0"/>
           </a:p>
         </p:txBody>
       </p:sp>
@@ -10235,7 +10235,7 @@
               </a:lnSpc>
             </a:pPr>
             <a:r>
-              <a:rPr lang="en-CA" sz="2000"/>
+              <a:rPr lang="en-CA" sz="2000" dirty="0"/>
               <a:t>Yeong Sir Chung</a:t>
             </a:r>
           </a:p>
@@ -10246,7 +10246,7 @@
               </a:lnSpc>
             </a:pPr>
             <a:r>
-              <a:rPr lang="en-CA" sz="2000"/>
+              <a:rPr lang="en-CA" sz="2000" dirty="0"/>
               <a:t>Matthew Roberto</a:t>
             </a:r>
           </a:p>
@@ -10257,9 +10257,90 @@
               </a:lnSpc>
             </a:pPr>
             <a:r>
-              <a:rPr lang="en-CA" sz="2000"/>
+              <a:rPr lang="en-CA" sz="2000" dirty="0"/>
               <a:t>Rohit Panda</a:t>
             </a:r>
+          </a:p>
+        </p:txBody>
+      </p:sp>
+      <p:sp>
+        <p:nvSpPr>
+          <p:cNvPr id="4" name="Title 1">
+            <a:extLst>
+              <a:ext uri="{FF2B5EF4-FFF2-40B4-BE49-F238E27FC236}">
+                <a16:creationId xmlns:a16="http://schemas.microsoft.com/office/drawing/2014/main" id="{9A8B0553-E47D-FA85-DF84-0BCA9D9FD706}"/>
+              </a:ext>
+            </a:extLst>
+          </p:cNvPr>
+          <p:cNvSpPr txBox="1">
+            <a:spLocks/>
+          </p:cNvSpPr>
+          <p:nvPr/>
+        </p:nvSpPr>
+        <p:spPr>
+          <a:xfrm>
+            <a:off x="-134813" y="6529891"/>
+            <a:ext cx="5868639" cy="656218"/>
+          </a:xfrm>
+          <a:prstGeom prst="rect">
+            <a:avLst/>
+          </a:prstGeom>
+        </p:spPr>
+        <p:txBody>
+          <a:bodyPr vert="horz" lIns="91440" tIns="45720" rIns="91440" bIns="45720" rtlCol="0" anchor="b">
+            <a:normAutofit fontScale="85000" lnSpcReduction="10000"/>
+          </a:bodyPr>
+          <a:lstStyle>
+            <a:lvl1pPr algn="l" defTabSz="914400" rtl="0" eaLnBrk="1" latinLnBrk="0" hangingPunct="1">
+              <a:lnSpc>
+                <a:spcPct val="85000"/>
+              </a:lnSpc>
+              <a:spcBef>
+                <a:spcPct val="0"/>
+              </a:spcBef>
+              <a:buNone/>
+              <a:defRPr lang="en-US" sz="4800" b="0" kern="1200" spc="-110" baseline="0" dirty="0">
+                <a:solidFill>
+                  <a:schemeClr val="tx1"/>
+                </a:solidFill>
+                <a:latin typeface="+mj-lt"/>
+                <a:ea typeface="+mj-ea"/>
+                <a:cs typeface="+mj-cs"/>
+              </a:defRPr>
+            </a:lvl1pPr>
+          </a:lstStyle>
+          <a:p>
+            <a:r>
+              <a:rPr lang="en-CA" sz="2800" dirty="0">
+                <a:solidFill>
+                  <a:schemeClr val="bg1"/>
+                </a:solidFill>
+              </a:rPr>
+              <a:t> </a:t>
+            </a:r>
+            <a:r>
+              <a:rPr lang="en-CA" sz="2800" dirty="0">
+                <a:solidFill>
+                  <a:schemeClr val="bg1"/>
+                </a:solidFill>
+                <a:hlinkClick r:id="rId3">
+                  <a:extLst>
+                    <a:ext uri="{A12FA001-AC4F-418D-AE19-62706E023703}">
+                      <ahyp:hlinkClr xmlns:ahyp="http://schemas.microsoft.com/office/drawing/2018/hyperlinkcolor" val="tx"/>
+                    </a:ext>
+                  </a:extLst>
+                </a:hlinkClick>
+              </a:rPr>
+              <a:t>https://roh00t.github.io/MatrixNotFound/</a:t>
+            </a:r>
+            <a:endParaRPr lang="en-CA" sz="2800" dirty="0">
+              <a:solidFill>
+                <a:schemeClr val="bg1"/>
+              </a:solidFill>
+            </a:endParaRPr>
+          </a:p>
+          <a:p>
+            <a:endParaRPr lang="en-CA" sz="3600" dirty="0"/>
           </a:p>
         </p:txBody>
       </p:sp>
@@ -10323,7 +10404,7 @@
           <a:p>
             <a:r>
               <a:rPr lang="en-GB"/>
-              <a:t xml:space="preserve">Buildings are a major contributor to carbon emissions. We built an </a:t>
+              <a:t>Buildings are a major contributor to carbon emissions. We built an </a:t>
             </a:r>
             <a:r>
               <a:rPr lang="en-GB" b="1"/>
@@ -10331,7 +10412,7 @@
             </a:r>
             <a:r>
               <a:rPr lang="en-GB"/>
-              <a:t xml:space="preserve"> that </a:t>
+              <a:t> that </a:t>
             </a:r>
             <a:r>
               <a:rPr lang="en-GB" b="1"/>
@@ -10339,7 +10420,7 @@
             </a:r>
             <a:r>
               <a:rPr lang="en-GB"/>
-              <a:t xml:space="preserve"> (site EUI) from known factors, such as:</a:t>
+              <a:t> (site EUI) from known factors, such as:</a:t>
             </a:r>
           </a:p>
           <a:p>
@@ -10385,7 +10466,7 @@
           <a:p>
             <a:r>
               <a:rPr lang="en-GB"/>
-              <a:t xml:space="preserve">Buildings that use far more energy than the model expects for similar buildings are the ones leaders should </a:t>
+              <a:t>Buildings that use far more energy than the model expects for similar buildings are the ones leaders should </a:t>
             </a:r>
             <a:r>
               <a:rPr lang="en-GB" b="1"/>
@@ -10714,7 +10795,7 @@
             </a:r>
             <a:r>
               <a:rPr lang="en-GB"/>
-              <a:t xml:space="preserve"> training building-years; </a:t>
+              <a:t> training building-years; </a:t>
             </a:r>
             <a:r>
               <a:rPr lang="en-GB" b="1"/>
@@ -10722,7 +10803,7 @@
             </a:r>
             <a:r>
               <a:rPr lang="en-GB"/>
-              <a:t xml:space="preserve"> test buildings.</a:t>
+              <a:t> test buildings.</a:t>
             </a:r>
           </a:p>
           <a:p>
@@ -10732,7 +10813,7 @@
             </a:pPr>
             <a:r>
               <a:rPr lang="en-GB"/>
-              <a:t xml:space="preserve">The test set is one </a:t>
+              <a:t>The test set is one </a:t>
             </a:r>
             <a:r>
               <a:rPr lang="en-GB" b="1"/>
@@ -10740,7 +10821,7 @@
             </a:r>
             <a:r>
               <a:rPr lang="en-GB"/>
-              <a:t xml:space="preserve"> (year 7) with no State 6 buildings, so we validate by holding out a whole year.</a:t>
+              <a:t> (year 7) with no State 6 buildings, so we validate by holding out a whole year.</a:t>
             </a:r>
           </a:p>
           <a:p>
@@ -10750,7 +10831,7 @@
             </a:pPr>
             <a:r>
               <a:rPr lang="en-GB"/>
-              <a:t xml:space="preserve">Energy Star rating is 35% missing: we filled gaps with </a:t>
+              <a:t>Energy Star rating is 35% missing: we filled gaps with </a:t>
             </a:r>
             <a:r>
               <a:rPr lang="en-GB" b="1"/>
@@ -10758,13 +10839,13 @@
             </a:r>
             <a:r>
               <a:rPr lang="en-GB"/>
-              <a:t xml:space="preserve"> and added "was missing" flags (no rows dropped).</a:t>
+              <a:t> and added "was missing" flags (no rows dropped).</a:t>
             </a:r>
           </a:p>
           <a:p>
             <a:r>
               <a:rPr lang="en-GB"/>
-              <a:t xml:space="preserve">On the test set, </a:t>
+              <a:t>On the test set, </a:t>
             </a:r>
             <a:r>
               <a:rPr lang="en-GB" b="1"/>
@@ -10772,7 +10853,7 @@
             </a:r>
             <a:r>
               <a:rPr lang="en-GB"/>
-              <a:t xml:space="preserve"> has the strongest correlation with site EUI (</a:t>
+              <a:t> has the strongest correlation with site EUI (</a:t>
             </a:r>
             <a:r>
               <a:rPr lang="en-GB" b="1"/>
@@ -11091,7 +11172,7 @@
             </a:r>
             <a:r>
               <a:rPr lang="en-GB"/>
-              <a:t xml:space="preserve"> (MATLAB </a:t>
+              <a:t> (MATLAB </a:t>
             </a:r>
             <a:r>
               <a:rPr lang="en-GB" b="1"/>
@@ -11113,7 +11194,7 @@
             </a:r>
             <a:r>
               <a:rPr lang="en-GB"/>
-              <a:t xml:space="preserve"> baseline → </a:t>
+              <a:t> baseline → </a:t>
             </a:r>
             <a:r>
               <a:rPr lang="en-GB" b="1"/>
@@ -11121,7 +11202,7 @@
             </a:r>
             <a:r>
               <a:rPr lang="en-GB"/>
-              <a:t xml:space="preserve"> (all features) → </a:t>
+              <a:t> (all features) → </a:t>
             </a:r>
             <a:r>
               <a:rPr lang="en-GB" b="1"/>
@@ -11129,7 +11210,7 @@
             </a:r>
             <a:r>
               <a:rPr lang="en-GB"/>
-              <a:t xml:space="preserve"> (shrinkage) → </a:t>
+              <a:t> (shrinkage) → </a:t>
             </a:r>
             <a:r>
               <a:rPr lang="en-GB" b="1"/>
@@ -11137,7 +11218,7 @@
             </a:r>
             <a:r>
               <a:rPr lang="en-GB"/>
-              <a:t xml:space="preserve"> (feature selection: drop 36 monthly temperatures)</a:t>
+              <a:t> (feature selection: drop 36 monthly temperatures)</a:t>
             </a:r>
           </a:p>
           <a:p>
@@ -11161,7 +11242,7 @@
             </a:r>
             <a:r>
               <a:rPr lang="en-GB"/>
-              <a:t xml:space="preserve"> validation, with cleaning refit inside every fold (no leakage)</a:t>
+              <a:t> validation, with cleaning refit inside every fold (no leakage)</a:t>
             </a:r>
           </a:p>
         </p:txBody>
@@ -11466,7 +11547,7 @@
             </a:r>
             <a:r>
               <a:rPr lang="en-GB"/>
-              <a:t xml:space="preserve"> is our final model:</a:t>
+              <a:t> is our final model:</a:t>
             </a:r>
           </a:p>
           <a:p>
@@ -11476,7 +11557,7 @@
             </a:pPr>
             <a:r>
               <a:rPr lang="en-GB"/>
-              <a:t xml:space="preserve">LOYO RMSE </a:t>
+              <a:t>LOYO RMSE </a:t>
             </a:r>
             <a:r>
               <a:rPr lang="en-GB" b="1"/>
@@ -11484,7 +11565,7 @@
             </a:r>
             <a:r>
               <a:rPr lang="en-GB"/>
-              <a:t xml:space="preserve">, </a:t>
+              <a:t>, </a:t>
             </a:r>
             <a:r>
               <a:rPr lang="en-GB" b="1"/>
@@ -11492,7 +11573,7 @@
             </a:r>
             <a:r>
               <a:rPr lang="en-GB"/>
-              <a:t xml:space="preserve"> lower than a single tree</a:t>
+              <a:t> lower than a single tree</a:t>
             </a:r>
           </a:p>
           <a:p>
@@ -11502,7 +11583,7 @@
             </a:pPr>
             <a:r>
               <a:rPr lang="en-GB"/>
-              <a:t xml:space="preserve">MAE </a:t>
+              <a:t>MAE </a:t>
             </a:r>
             <a:r>
               <a:rPr lang="en-GB" b="1"/>
@@ -11510,7 +11591,7 @@
             </a:r>
             <a:r>
               <a:rPr lang="en-GB"/>
-              <a:t xml:space="preserve"> kBtu/ft²/yr and R² </a:t>
+              <a:t> kBtu/ft²/yr and R² </a:t>
             </a:r>
             <a:r>
               <a:rPr lang="en-GB" b="1"/>
@@ -11518,7 +11599,7 @@
             </a:r>
             <a:r>
               <a:rPr lang="en-GB"/>
-              <a:t xml:space="preserve"> on years it never saw</a:t>
+              <a:t> on years it never saw</a:t>
             </a:r>
           </a:p>
           <a:p>
@@ -11528,7 +11609,7 @@
             </a:pPr>
             <a:r>
               <a:rPr lang="en-GB"/>
-              <a:t xml:space="preserve">Best in </a:t>
+              <a:t>Best in </a:t>
             </a:r>
             <a:r>
               <a:rPr lang="en-GB" b="1"/>
@@ -11536,7 +11617,7 @@
             </a:r>
             <a:r>
               <a:rPr lang="en-GB"/>
-              <a:t xml:space="preserve"> held-out years</a:t>
+              <a:t> held-out years</a:t>
             </a:r>
           </a:p>
           <a:p>
@@ -11774,13 +11855,13 @@
           <p:nvPr>
             <p:extLst>
               <p:ext uri="{D42A27DB-BD31-4B8C-83A1-F6EECF244321}">
-                <p14:modId xmlns:p14="http://schemas.microsoft.com/office/powerpoint/2010/main" val="2038214847"/>
+                <p14:modId xmlns:p14="http://schemas.microsoft.com/office/powerpoint/2010/main" val="1620249687"/>
               </p:ext>
             </p:extLst>
           </p:nvPr>
         </p:nvGraphicFramePr>
         <p:xfrm>
-          <a:off x="5523910" y="1719215"/>
+          <a:off x="5532074" y="1516472"/>
           <a:ext cx="5916980" cy="1854200"/>
         </p:xfrm>
         <a:graphic>
@@ -12133,7 +12214,7 @@
                     <a:lstStyle/>
                     <a:p>
                       <a:r>
-                        <a:rPr lang="en-CA"/>
+                        <a:rPr lang="en-CA" dirty="0"/>
                         <a:t>−34%</a:t>
                       </a:r>
                     </a:p>
@@ -12194,7 +12275,7 @@
           <p:nvPr/>
         </p:nvPicPr>
         <p:blipFill>
-          <a:blip r:embed="rId2"/>
+          <a:blip r:embed="rId4"/>
           <a:stretch>
             <a:fillRect/>
           </a:stretch>
@@ -12272,7 +12353,7 @@
           <a:lstStyle/>
           <a:p>
             <a:r>
-              <a:rPr lang="en-GB"/>
+              <a:rPr lang="en-GB" dirty="0"/>
               <a:t>Controlled experiment: same data and folds, only the model changes.</a:t>
             </a:r>
           </a:p>
@@ -12282,12 +12363,30 @@
               <a:buChar char="•"/>
             </a:pPr>
             <a:r>
-              <a:rPr lang="en-GB" b="1"/>
+              <a:rPr lang="en-GB" b="1" dirty="0"/>
               <a:t>M1</a:t>
             </a:r>
             <a:r>
-              <a:rPr lang="en-GB"/>
-              <a:t>: tree, all cleaned factors</a:t>
+              <a:rPr lang="en-GB" dirty="0"/>
+              <a:t>: </a:t>
+            </a:r>
+            <a:r>
+              <a:rPr lang="en-GB" dirty="0" err="1"/>
+              <a:t>LSBoost</a:t>
+            </a:r>
+            <a:r>
+              <a:rPr lang="en-GB" dirty="0"/>
+              <a:t> </a:t>
+            </a:r>
+            <a:r>
+              <a:rPr lang="en-GB" dirty="0">
+                <a:sym typeface="Wingdings" pitchFamily="2" charset="2"/>
+              </a:rPr>
+              <a:t></a:t>
+            </a:r>
+            <a:r>
+              <a:rPr lang="en-GB" dirty="0"/>
+              <a:t> single regression tree, all cleaned factors</a:t>
             </a:r>
           </a:p>
           <a:p>
@@ -12296,12 +12395,26 @@
               <a:buChar char="•"/>
             </a:pPr>
             <a:r>
-              <a:rPr lang="en-GB" b="1"/>
-              <a:t>M2</a:t>
-            </a:r>
-            <a:r>
-              <a:rPr lang="en-GB"/>
-              <a:t>: tree, 8 selected factors</a:t>
+              <a:rPr lang="en-GB" b="1" dirty="0"/>
+              <a:t>M2 </a:t>
+            </a:r>
+            <a:r>
+              <a:rPr lang="en-GB" dirty="0">
+                <a:sym typeface="Wingdings" pitchFamily="2" charset="2"/>
+              </a:rPr>
+              <a:t></a:t>
+            </a:r>
+            <a:r>
+              <a:rPr lang="en-GB" dirty="0"/>
+              <a:t> single regression tree : </a:t>
+            </a:r>
+            <a:r>
+              <a:rPr lang="en-GB" dirty="0" err="1"/>
+              <a:t>LSBoost</a:t>
+            </a:r>
+            <a:r>
+              <a:rPr lang="en-GB" dirty="0"/>
+              <a:t>, 8 selected factors</a:t>
             </a:r>
           </a:p>
           <a:p>
@@ -12310,26 +12423,34 @@
               <a:buChar char="•"/>
             </a:pPr>
             <a:r>
-              <a:rPr lang="en-GB" b="1"/>
+              <a:rPr lang="en-GB" b="1" dirty="0"/>
               <a:t>M3</a:t>
             </a:r>
             <a:r>
-              <a:rPr lang="en-GB"/>
-              <a:t>: LSBoost, 8 selected factors</a:t>
-            </a:r>
-          </a:p>
-          <a:p>
-            <a:r>
-              <a:rPr lang="en-GB"/>
-              <a:t xml:space="preserve">Boosting on selected features wins on </a:t>
-            </a:r>
-            <a:r>
-              <a:rPr lang="en-GB" b="1"/>
+              <a:rPr lang="en-GB" dirty="0"/>
+              <a:t>: </a:t>
+            </a:r>
+            <a:r>
+              <a:rPr lang="en-GB" dirty="0" err="1"/>
+              <a:t>LSBoost</a:t>
+            </a:r>
+            <a:r>
+              <a:rPr lang="en-GB" dirty="0"/>
+              <a:t> (300 Trees), 8 selected factors</a:t>
+            </a:r>
+          </a:p>
+          <a:p>
+            <a:r>
+              <a:rPr lang="en-GB" dirty="0"/>
+              <a:t>Boosting on selected features wins on </a:t>
+            </a:r>
+            <a:r>
+              <a:rPr lang="en-GB" b="1" dirty="0"/>
               <a:t>every metric</a:t>
             </a:r>
             <a:r>
-              <a:rPr lang="en-GB"/>
-              <a:t xml:space="preserve"> under both validations, consistent with the official result.</a:t>
+              <a:rPr lang="en-GB" dirty="0"/>
+              <a:t> under both validations, consistent with the official result.</a:t>
             </a:r>
           </a:p>
         </p:txBody>
@@ -12557,13 +12678,13 @@
           <p:nvPr>
             <p:extLst>
               <p:ext uri="{D42A27DB-BD31-4B8C-83A1-F6EECF244321}">
-                <p14:modId xmlns:p14="http://schemas.microsoft.com/office/powerpoint/2010/main" val="2038214847"/>
+                <p14:modId xmlns:p14="http://schemas.microsoft.com/office/powerpoint/2010/main" val="3223028419"/>
               </p:ext>
             </p:extLst>
           </p:nvPr>
         </p:nvGraphicFramePr>
         <p:xfrm>
-          <a:off x="5523910" y="1719215"/>
+          <a:off x="5523910" y="1165500"/>
           <a:ext cx="5916980" cy="1854200"/>
         </p:xfrm>
         <a:graphic>
@@ -12916,7 +13037,7 @@
                     <a:lstStyle/>
                     <a:p>
                       <a:r>
-                        <a:rPr lang="en-CA"/>
+                        <a:rPr lang="en-CA" dirty="0"/>
                         <a:t>0.5005</a:t>
                       </a:r>
                     </a:p>
@@ -13361,7 +13482,7 @@
       </p:graphicFrame>
       <p:sp>
         <p:nvSpPr>
-          <p:cNvPr id="9" name="TextBox 8">
+          <p:cNvPr id="6" name="TextBox 8">
             <a:extLst>
               <a:ext uri="{FF2B5EF4-FFF2-40B4-BE49-F238E27FC236}">
                 <a16:creationId xmlns:a16="http://schemas.microsoft.com/office/drawing/2014/main" id="{7663050F-8CD2-3FBD-6C05-0DF0F366B857}"/>
@@ -13468,7 +13589,7 @@
             </a:pPr>
             <a:r>
               <a:rPr lang="en-GB"/>
-              <a:t xml:space="preserve">Centred on zero (M3 mean bias </a:t>
+              <a:t>Centred on zero (M3 mean bias </a:t>
             </a:r>
             <a:r>
               <a:rPr lang="en-GB" b="1"/>
@@ -13496,7 +13617,7 @@
             </a:pPr>
             <a:r>
               <a:rPr lang="en-GB"/>
-              <a:t xml:space="preserve">Long negative tail: a few buildings use </a:t>
+              <a:t>Long negative tail: a few buildings use </a:t>
             </a:r>
             <a:r>
               <a:rPr lang="en-GB" b="1"/>
@@ -13504,13 +13625,13 @@
             </a:r>
             <a:r>
               <a:rPr lang="en-GB"/>
-              <a:t xml:space="preserve"> than predicted</a:t>
+              <a:t> than predicted</a:t>
             </a:r>
           </a:p>
           <a:p>
             <a:r>
               <a:rPr lang="en-GB"/>
-              <a:t xml:space="preserve">Those outliers are exactly what </a:t>
+              <a:t>Those outliers are exactly what </a:t>
             </a:r>
             <a:r>
               <a:rPr lang="en-GB" b="1"/>
@@ -13518,7 +13639,7 @@
             </a:r>
             <a:r>
               <a:rPr lang="en-GB"/>
-              <a:t xml:space="preserve"> flags.</a:t>
+              <a:t> flags.</a:t>
             </a:r>
           </a:p>
         </p:txBody>
@@ -13840,7 +13961,7 @@
       </p:sp>
       <p:sp>
         <p:nvSpPr>
-          <p:cNvPr id="9" name="TextBox 8">
+          <p:cNvPr id="5" name="TextBox 8">
             <a:extLst>
               <a:ext uri="{FF2B5EF4-FFF2-40B4-BE49-F238E27FC236}">
                 <a16:creationId xmlns:a16="http://schemas.microsoft.com/office/drawing/2014/main" id="{7663050F-8CD2-3FBD-6C05-0DF0F366B857}"/>
@@ -13875,7 +13996,7 @@
       </p:sp>
       <p:sp>
         <p:nvSpPr>
-          <p:cNvPr id="9" name="TextBox 8">
+          <p:cNvPr id="6" name="TextBox 8">
             <a:extLst>
               <a:ext uri="{FF2B5EF4-FFF2-40B4-BE49-F238E27FC236}">
                 <a16:creationId xmlns:a16="http://schemas.microsoft.com/office/drawing/2014/main" id="{7663050F-8CD2-3FBD-6C05-0DF0F366B857}"/>
@@ -13972,7 +14093,7 @@
             </a:r>
             <a:r>
               <a:rPr lang="en-GB"/>
-              <a:t xml:space="preserve"> compares each building's actual energy use with what the model expects for similar buildings:</a:t>
+              <a:t> compares each building's actual energy use with what the model expects for similar buildings:</a:t>
             </a:r>
           </a:p>
           <a:p>
@@ -13986,7 +14107,7 @@
             </a:r>
             <a:r>
               <a:rPr lang="en-GB"/>
-              <a:t xml:space="preserve"> buildings use 50%+ more than expected</a:t>
+              <a:t> buildings use 50%+ more than expected</a:t>
             </a:r>
           </a:p>
           <a:p>
@@ -13996,7 +14117,7 @@
             </a:pPr>
             <a:r>
               <a:rPr lang="en-GB"/>
-              <a:t xml:space="preserve">The top 50 account for </a:t>
+              <a:t>The top 50 account for </a:t>
             </a:r>
             <a:r>
               <a:rPr lang="en-GB" b="1"/>
@@ -14004,7 +14125,7 @@
             </a:r>
             <a:r>
               <a:rPr lang="en-GB"/>
-              <a:t xml:space="preserve"> of excess energy</a:t>
+              <a:t> of excess energy</a:t>
             </a:r>
           </a:p>
           <a:p>
@@ -14014,7 +14135,7 @@
             </a:r>
             <a:r>
               <a:rPr lang="en-GB"/>
-              <a:t xml:space="preserve">: click NTU's The Hive or The Arc and our trained model runs </a:t>
+              <a:t>: click NTU's The Hive or The Arc and our trained model runs </a:t>
             </a:r>
             <a:r>
               <a:rPr lang="en-GB" b="1"/>
@@ -14028,7 +14149,7 @@
           <a:p>
             <a:r>
               <a:rPr lang="en-GB"/>
-              <a:t xml:space="preserve">Open </a:t>
+              <a:t>Open </a:t>
             </a:r>
             <a:r>
               <a:rPr lang="en-GB" b="1"/>
@@ -14036,7 +14157,7 @@
             </a:r>
             <a:r>
               <a:rPr lang="en-GB"/>
-              <a:t xml:space="preserve"> in the repository for the dashboard, simulator and report.</a:t>
+              <a:t> in the repository for the dashboard, simulator and report.</a:t>
             </a:r>
           </a:p>
         </p:txBody>
@@ -14268,7 +14389,7 @@
           <p:nvPr/>
         </p:nvPicPr>
         <p:blipFill>
-          <a:blip r:embed="rId2"/>
+          <a:blip r:embed="rId4"/>
           <a:stretch>
             <a:fillRect/>
           </a:stretch>
@@ -14283,6 +14404,49 @@
           </a:prstGeom>
         </p:spPr>
       </p:pic>
+      <p:sp>
+        <p:nvSpPr>
+          <p:cNvPr id="6" name="TextBox 5">
+            <a:extLst>
+              <a:ext uri="{FF2B5EF4-FFF2-40B4-BE49-F238E27FC236}">
+                <a16:creationId xmlns:a16="http://schemas.microsoft.com/office/drawing/2014/main" id="{A618C61A-1439-1A63-2CFC-9424379C8A51}"/>
+              </a:ext>
+            </a:extLst>
+          </p:cNvPr>
+          <p:cNvSpPr txBox="1"/>
+          <p:nvPr/>
+        </p:nvSpPr>
+        <p:spPr>
+          <a:xfrm>
+            <a:off x="6096000" y="5056745"/>
+            <a:ext cx="6099586" cy="369332"/>
+          </a:xfrm>
+          <a:prstGeom prst="rect">
+            <a:avLst/>
+          </a:prstGeom>
+          <a:noFill/>
+        </p:spPr>
+        <p:txBody>
+          <a:bodyPr wrap="square">
+            <a:spAutoFit/>
+          </a:bodyPr>
+          <a:lstStyle/>
+          <a:p>
+            <a:r>
+              <a:rPr lang="en-US" dirty="0"/>
+              <a:t>https://roh00t.github.io/</a:t>
+            </a:r>
+            <a:r>
+              <a:rPr lang="en-US" dirty="0" err="1"/>
+              <a:t>MatrixNotFound</a:t>
+            </a:r>
+            <a:r>
+              <a:rPr lang="en-US" dirty="0"/>
+              <a:t>/</a:t>
+            </a:r>
+          </a:p>
+        </p:txBody>
+      </p:sp>
     </p:spTree>
     <p:extLst>
       <p:ext uri="{BB962C8B-B14F-4D97-AF65-F5344CB8AC3E}">
@@ -14347,7 +14511,7 @@
           <a:p>
             <a:r>
               <a:rPr lang="en-GB"/>
-              <a:t xml:space="preserve">Our best model is </a:t>
+              <a:t>Our best model is </a:t>
             </a:r>
             <a:r>
               <a:rPr lang="en-GB" b="1"/>
@@ -14355,7 +14519,7 @@
             </a:r>
             <a:r>
               <a:rPr lang="en-GB"/>
-              <a:t xml:space="preserve">: LOYO RMSE </a:t>
+              <a:t>: LOYO RMSE </a:t>
             </a:r>
             <a:r>
               <a:rPr lang="en-GB" b="1"/>
@@ -14363,7 +14527,7 @@
             </a:r>
             <a:r>
               <a:rPr lang="en-GB"/>
-              <a:t xml:space="preserve">, MAE </a:t>
+              <a:t>, MAE </a:t>
             </a:r>
             <a:r>
               <a:rPr lang="en-GB" b="1"/>
@@ -14371,7 +14535,7 @@
             </a:r>
             <a:r>
               <a:rPr lang="en-GB"/>
-              <a:t xml:space="preserve">, R² </a:t>
+              <a:t>, R² </a:t>
             </a:r>
             <a:r>
               <a:rPr lang="en-GB" b="1"/>
@@ -14388,7 +14552,7 @@
           <a:p>
             <a:r>
               <a:rPr lang="en-GB"/>
-              <a:t xml:space="preserve">In real-world use, </a:t>
+              <a:t>In real-world use, </a:t>
             </a:r>
             <a:r>
               <a:rPr lang="en-GB" b="1"/>
@@ -14396,7 +14560,7 @@
             </a:r>
             <a:r>
               <a:rPr lang="en-GB"/>
-              <a:t xml:space="preserve"> turns predictions into a ranked audit list: the buildings using far more energy than their peers.</a:t>
+              <a:t> turns predictions into a ranked audit list: the buildings using far more energy than their peers.</a:t>
             </a:r>
           </a:p>
           <a:p>
@@ -15199,20 +15363,20 @@
 </file>
 
 <file path=customXml/item1.xml><?xml version="1.0" encoding="utf-8"?>
+<p:properties xmlns:p="http://schemas.microsoft.com/office/2006/metadata/properties" xmlns:xsi="http://www.w3.org/2001/XMLSchema-instance" xmlns:pc="http://schemas.microsoft.com/office/infopath/2007/PartnerControls">
+  <documentManagement>
+    <_activity xmlns="730065ae-0c4e-4fe2-83da-e378abc56499" xsi:nil="true"/>
+  </documentManagement>
+</p:properties>
+</file>
+
+<file path=customXml/item2.xml><?xml version="1.0" encoding="utf-8"?>
 <?mso-contentType ?>
 <FormTemplates xmlns="http://schemas.microsoft.com/sharepoint/v3/contenttype/forms">
   <Display>DocumentLibraryForm</Display>
   <Edit>DocumentLibraryForm</Edit>
   <New>DocumentLibraryForm</New>
 </FormTemplates>
-</file>
-
-<file path=customXml/item2.xml><?xml version="1.0" encoding="utf-8"?>
-<p:properties xmlns:p="http://schemas.microsoft.com/office/2006/metadata/properties" xmlns:xsi="http://www.w3.org/2001/XMLSchema-instance" xmlns:pc="http://schemas.microsoft.com/office/infopath/2007/PartnerControls">
-  <documentManagement>
-    <_activity xmlns="730065ae-0c4e-4fe2-83da-e378abc56499" xsi:nil="true"/>
-  </documentManagement>
-</p:properties>
 </file>
 
 <file path=customXml/item3.xml><?xml version="1.0" encoding="utf-8"?>
@@ -15443,14 +15607,6 @@
 </file>
 
 <file path=customXml/itemProps1.xml><?xml version="1.0" encoding="utf-8"?>
-<ds:datastoreItem xmlns:ds="http://schemas.openxmlformats.org/officeDocument/2006/customXml" ds:itemID="{55C5025F-1B4F-4EAE-9783-53EFA569F4D6}">
-  <ds:schemaRefs>
-    <ds:schemaRef ds:uri="http://schemas.microsoft.com/sharepoint/v3/contenttype/forms"/>
-  </ds:schemaRefs>
-</ds:datastoreItem>
-</file>
-
-<file path=customXml/itemProps2.xml><?xml version="1.0" encoding="utf-8"?>
 <ds:datastoreItem xmlns:ds="http://schemas.openxmlformats.org/officeDocument/2006/customXml" ds:itemID="{0AA2BE0D-00EC-41B7-B8C6-AEF807D66DF3}">
   <ds:schemaRefs>
     <ds:schemaRef ds:uri="25af2e44-3863-4f07-bc1c-5e8baf608108"/>
@@ -15463,6 +15619,14 @@
     <ds:schemaRef ds:uri="http://schemas.microsoft.com/office/infopath/2007/PartnerControls"/>
     <ds:schemaRef ds:uri="http://schemas.openxmlformats.org/package/2006/metadata/core-properties"/>
     <ds:schemaRef ds:uri="http://www.w3.org/XML/1998/namespace"/>
+  </ds:schemaRefs>
+</ds:datastoreItem>
+</file>
+
+<file path=customXml/itemProps2.xml><?xml version="1.0" encoding="utf-8"?>
+<ds:datastoreItem xmlns:ds="http://schemas.openxmlformats.org/officeDocument/2006/customXml" ds:itemID="{55C5025F-1B4F-4EAE-9783-53EFA569F4D6}">
+  <ds:schemaRefs>
+    <ds:schemaRef ds:uri="http://schemas.microsoft.com/sharepoint/v3/contenttype/forms"/>
   </ds:schemaRefs>
 </ds:datastoreItem>
 </file>

</xml_diff>